<commit_message>
stuff i cant remember
stuff i cant remember
</commit_message>
<xml_diff>
--- a/Project_2_LE_Python_Analysis/LE_Analysis_Presentation.pptx
+++ b/Project_2_LE_Python_Analysis/LE_Analysis_Presentation.pptx
@@ -496,12 +496,6 @@
             <c:idx val="0"/>
             <c:invertIfNegative val="0"/>
             <c:bubble3D val="0"/>
-            <c:spPr>
-              <a:solidFill>
-                <a:srgbClr val="2CA58D"/>
-              </a:solidFill>
-              <a:effectLst/>
-            </c:spPr>
             <c:extLst>
               <c:ext xmlns:c16="http://schemas.microsoft.com/office/drawing/2014/chart" uri="{C3380CC4-5D6E-409C-BE32-E72D297353CC}">
                 <c16:uniqueId val="{00000001-870E-46E8-8CC7-0CCE8D629003}"/>
@@ -512,12 +506,6 @@
             <c:idx val="1"/>
             <c:invertIfNegative val="0"/>
             <c:bubble3D val="0"/>
-            <c:spPr>
-              <a:solidFill>
-                <a:srgbClr val="2CA58D"/>
-              </a:solidFill>
-              <a:effectLst/>
-            </c:spPr>
             <c:extLst>
               <c:ext xmlns:c16="http://schemas.microsoft.com/office/drawing/2014/chart" uri="{C3380CC4-5D6E-409C-BE32-E72D297353CC}">
                 <c16:uniqueId val="{00000003-870E-46E8-8CC7-0CCE8D629003}"/>
@@ -528,12 +516,6 @@
             <c:idx val="2"/>
             <c:invertIfNegative val="0"/>
             <c:bubble3D val="0"/>
-            <c:spPr>
-              <a:solidFill>
-                <a:srgbClr val="2CA58D"/>
-              </a:solidFill>
-              <a:effectLst/>
-            </c:spPr>
             <c:extLst>
               <c:ext xmlns:c16="http://schemas.microsoft.com/office/drawing/2014/chart" uri="{C3380CC4-5D6E-409C-BE32-E72D297353CC}">
                 <c16:uniqueId val="{00000005-870E-46E8-8CC7-0CCE8D629003}"/>

</xml_diff>